<commit_message>
Update plots: consistent labels
</commit_message>
<xml_diff>
--- a/figures/figures.pptx
+++ b/figures/figures.pptx
@@ -9,9 +9,8 @@
     <p:sldId id="264" r:id="rId3"/>
     <p:sldId id="265" r:id="rId4"/>
     <p:sldId id="266" r:id="rId5"/>
-    <p:sldId id="267" r:id="rId6"/>
-    <p:sldId id="269" r:id="rId7"/>
-    <p:sldId id="268" r:id="rId8"/>
+    <p:sldId id="269" r:id="rId6"/>
+    <p:sldId id="268" r:id="rId7"/>
   </p:sldIdLst>
   <p:sldSz cx="12192000" cy="6858000"/>
   <p:notesSz cx="6858000" cy="9144000"/>
@@ -265,7 +264,7 @@
           <a:p>
             <a:fld id="{75A9CF98-CC55-774D-9AE2-4D7D2CE05F38}" type="datetimeFigureOut">
               <a:rPr lang="en-US" smtClean="0"/>
-              <a:t>10/22/25</a:t>
+              <a:t>10/23/25</a:t>
             </a:fld>
             <a:endParaRPr lang="en-US"/>
           </a:p>
@@ -463,7 +462,7 @@
           <a:p>
             <a:fld id="{75A9CF98-CC55-774D-9AE2-4D7D2CE05F38}" type="datetimeFigureOut">
               <a:rPr lang="en-US" smtClean="0"/>
-              <a:t>10/22/25</a:t>
+              <a:t>10/23/25</a:t>
             </a:fld>
             <a:endParaRPr lang="en-US"/>
           </a:p>
@@ -671,7 +670,7 @@
           <a:p>
             <a:fld id="{75A9CF98-CC55-774D-9AE2-4D7D2CE05F38}" type="datetimeFigureOut">
               <a:rPr lang="en-US" smtClean="0"/>
-              <a:t>10/22/25</a:t>
+              <a:t>10/23/25</a:t>
             </a:fld>
             <a:endParaRPr lang="en-US"/>
           </a:p>
@@ -869,7 +868,7 @@
           <a:p>
             <a:fld id="{75A9CF98-CC55-774D-9AE2-4D7D2CE05F38}" type="datetimeFigureOut">
               <a:rPr lang="en-US" smtClean="0"/>
-              <a:t>10/22/25</a:t>
+              <a:t>10/23/25</a:t>
             </a:fld>
             <a:endParaRPr lang="en-US"/>
           </a:p>
@@ -1144,7 +1143,7 @@
           <a:p>
             <a:fld id="{75A9CF98-CC55-774D-9AE2-4D7D2CE05F38}" type="datetimeFigureOut">
               <a:rPr lang="en-US" smtClean="0"/>
-              <a:t>10/22/25</a:t>
+              <a:t>10/23/25</a:t>
             </a:fld>
             <a:endParaRPr lang="en-US"/>
           </a:p>
@@ -1409,7 +1408,7 @@
           <a:p>
             <a:fld id="{75A9CF98-CC55-774D-9AE2-4D7D2CE05F38}" type="datetimeFigureOut">
               <a:rPr lang="en-US" smtClean="0"/>
-              <a:t>10/22/25</a:t>
+              <a:t>10/23/25</a:t>
             </a:fld>
             <a:endParaRPr lang="en-US"/>
           </a:p>
@@ -1821,7 +1820,7 @@
           <a:p>
             <a:fld id="{75A9CF98-CC55-774D-9AE2-4D7D2CE05F38}" type="datetimeFigureOut">
               <a:rPr lang="en-US" smtClean="0"/>
-              <a:t>10/22/25</a:t>
+              <a:t>10/23/25</a:t>
             </a:fld>
             <a:endParaRPr lang="en-US"/>
           </a:p>
@@ -1962,7 +1961,7 @@
           <a:p>
             <a:fld id="{75A9CF98-CC55-774D-9AE2-4D7D2CE05F38}" type="datetimeFigureOut">
               <a:rPr lang="en-US" smtClean="0"/>
-              <a:t>10/22/25</a:t>
+              <a:t>10/23/25</a:t>
             </a:fld>
             <a:endParaRPr lang="en-US"/>
           </a:p>
@@ -2075,7 +2074,7 @@
           <a:p>
             <a:fld id="{75A9CF98-CC55-774D-9AE2-4D7D2CE05F38}" type="datetimeFigureOut">
               <a:rPr lang="en-US" smtClean="0"/>
-              <a:t>10/22/25</a:t>
+              <a:t>10/23/25</a:t>
             </a:fld>
             <a:endParaRPr lang="en-US"/>
           </a:p>
@@ -2386,7 +2385,7 @@
           <a:p>
             <a:fld id="{75A9CF98-CC55-774D-9AE2-4D7D2CE05F38}" type="datetimeFigureOut">
               <a:rPr lang="en-US" smtClean="0"/>
-              <a:t>10/22/25</a:t>
+              <a:t>10/23/25</a:t>
             </a:fld>
             <a:endParaRPr lang="en-US"/>
           </a:p>
@@ -2674,7 +2673,7 @@
           <a:p>
             <a:fld id="{75A9CF98-CC55-774D-9AE2-4D7D2CE05F38}" type="datetimeFigureOut">
               <a:rPr lang="en-US" smtClean="0"/>
-              <a:t>10/22/25</a:t>
+              <a:t>10/23/25</a:t>
             </a:fld>
             <a:endParaRPr lang="en-US"/>
           </a:p>
@@ -2915,7 +2914,7 @@
           <a:p>
             <a:fld id="{75A9CF98-CC55-774D-9AE2-4D7D2CE05F38}" type="datetimeFigureOut">
               <a:rPr lang="en-US" smtClean="0"/>
-              <a:t>10/22/25</a:t>
+              <a:t>10/23/25</a:t>
             </a:fld>
             <a:endParaRPr lang="en-US"/>
           </a:p>
@@ -3390,23 +3389,8 @@
                       </a:solidFill>
                       <a:latin typeface="Aptos" panose="020B0004020202020204" pitchFamily="34" charset="0"/>
                     </a:rPr>
-                    <a:t>1. </a:t>
+                    <a:t>1. SINDy</a:t>
                   </a:r>
-                  <a:r>
-                    <a:rPr lang="en-US" b="1" dirty="0" err="1">
-                      <a:solidFill>
-                        <a:schemeClr val="tx1"/>
-                      </a:solidFill>
-                      <a:latin typeface="Aptos" panose="020B0004020202020204" pitchFamily="34" charset="0"/>
-                    </a:rPr>
-                    <a:t>SINDy</a:t>
-                  </a:r>
-                  <a:endParaRPr lang="en-US" b="1" dirty="0">
-                    <a:solidFill>
-                      <a:schemeClr val="tx1"/>
-                    </a:solidFill>
-                    <a:latin typeface="Aptos" panose="020B0004020202020204" pitchFamily="34" charset="0"/>
-                  </a:endParaRPr>
                 </a:p>
                 <a:p>
                   <a:pPr algn="ctr"/>
@@ -3614,7 +3598,7 @@
                       </a:solidFill>
                       <a:latin typeface="Aptos" panose="020B0004020202020204" pitchFamily="34" charset="0"/>
                     </a:rPr>
-                    <a:t>2. NN-driven</a:t>
+                    <a:t>2. NN-derivative</a:t>
                   </a:r>
                 </a:p>
                 <a:p>
@@ -8031,10 +8015,10 @@
       </p:pic>
       <p:pic>
         <p:nvPicPr>
-          <p:cNvPr id="15" name="Picture 14">
-            <a:extLst>
-              <a:ext uri="{FF2B5EF4-FFF2-40B4-BE49-F238E27FC236}">
-                <a16:creationId xmlns:a16="http://schemas.microsoft.com/office/drawing/2014/main" id="{4422557D-440D-7C4A-127F-99CF8FA8CB29}"/>
+          <p:cNvPr id="4" name="Picture 3">
+            <a:extLst>
+              <a:ext uri="{FF2B5EF4-FFF2-40B4-BE49-F238E27FC236}">
+                <a16:creationId xmlns:a16="http://schemas.microsoft.com/office/drawing/2014/main" id="{B2E06A5C-8DD2-9C99-A6C1-E3C1B6BC8703}"/>
               </a:ext>
             </a:extLst>
           </p:cNvPr>
@@ -8045,6 +8029,37 @@
         </p:nvPicPr>
         <p:blipFill>
           <a:blip r:embed="rId3"/>
+          <a:srcRect r="18824"/>
+          <a:stretch>
+            <a:fillRect/>
+          </a:stretch>
+        </p:blipFill>
+        <p:spPr>
+          <a:xfrm>
+            <a:off x="-994" y="1983522"/>
+            <a:ext cx="3746004" cy="3463508"/>
+          </a:xfrm>
+          <a:prstGeom prst="rect">
+            <a:avLst/>
+          </a:prstGeom>
+        </p:spPr>
+      </p:pic>
+      <p:pic>
+        <p:nvPicPr>
+          <p:cNvPr id="15" name="Picture 14">
+            <a:extLst>
+              <a:ext uri="{FF2B5EF4-FFF2-40B4-BE49-F238E27FC236}">
+                <a16:creationId xmlns:a16="http://schemas.microsoft.com/office/drawing/2014/main" id="{4422557D-440D-7C4A-127F-99CF8FA8CB29}"/>
+              </a:ext>
+            </a:extLst>
+          </p:cNvPr>
+          <p:cNvPicPr>
+            <a:picLocks noChangeAspect="1"/>
+          </p:cNvPicPr>
+          <p:nvPr/>
+        </p:nvPicPr>
+        <p:blipFill>
+          <a:blip r:embed="rId4"/>
           <a:srcRect l="2193" r="24776"/>
           <a:stretch>
             <a:fillRect/>
@@ -8102,23 +8117,8 @@
                 </a:solidFill>
                 <a:latin typeface="Aptos" panose="020B0004020202020204" pitchFamily="34" charset="0"/>
               </a:rPr>
-              <a:t> </a:t>
-            </a:r>
-            <a:r>
-              <a:rPr lang="en-US" b="1" dirty="0" err="1">
-                <a:solidFill>
-                  <a:schemeClr val="tx1"/>
-                </a:solidFill>
-                <a:latin typeface="Aptos" panose="020B0004020202020204" pitchFamily="34" charset="0"/>
-              </a:rPr>
-              <a:t>SINDy</a:t>
-            </a:r>
-            <a:endParaRPr lang="en-US" b="1" dirty="0">
-              <a:solidFill>
-                <a:schemeClr val="tx1"/>
-              </a:solidFill>
-              <a:latin typeface="Aptos" panose="020B0004020202020204" pitchFamily="34" charset="0"/>
-            </a:endParaRPr>
+              <a:t> SINDy</a:t>
+            </a:r>
           </a:p>
         </p:txBody>
       </p:sp>
@@ -8136,7 +8136,7 @@
         </p:nvSpPr>
         <p:spPr>
           <a:xfrm>
-            <a:off x="3548031" y="1968080"/>
+            <a:off x="3717303" y="1944585"/>
             <a:ext cx="2259479" cy="369332"/>
           </a:xfrm>
           <a:prstGeom prst="rect">
@@ -8164,7 +8164,7 @@
                 </a:solidFill>
                 <a:latin typeface="Aptos" panose="020B0004020202020204" pitchFamily="34" charset="0"/>
               </a:rPr>
-              <a:t> NN-driven</a:t>
+              <a:t> NN-derivative</a:t>
             </a:r>
           </a:p>
         </p:txBody>
@@ -8216,37 +8216,6 @@
           </a:p>
         </p:txBody>
       </p:sp>
-      <p:pic>
-        <p:nvPicPr>
-          <p:cNvPr id="6" name="Picture 5">
-            <a:extLst>
-              <a:ext uri="{FF2B5EF4-FFF2-40B4-BE49-F238E27FC236}">
-                <a16:creationId xmlns:a16="http://schemas.microsoft.com/office/drawing/2014/main" id="{327ABC7B-0D8F-75BD-855A-D6C65BF61F9A}"/>
-              </a:ext>
-            </a:extLst>
-          </p:cNvPr>
-          <p:cNvPicPr>
-            <a:picLocks noChangeAspect="1"/>
-          </p:cNvPicPr>
-          <p:nvPr/>
-        </p:nvPicPr>
-        <p:blipFill>
-          <a:blip r:embed="rId4"/>
-          <a:srcRect l="7939" t="9471" r="18510" b="3182"/>
-          <a:stretch>
-            <a:fillRect/>
-          </a:stretch>
-        </p:blipFill>
-        <p:spPr>
-          <a:xfrm>
-            <a:off x="199391" y="2325122"/>
-            <a:ext cx="3550528" cy="3164727"/>
-          </a:xfrm>
-          <a:prstGeom prst="rect">
-            <a:avLst/>
-          </a:prstGeom>
-        </p:spPr>
-      </p:pic>
     </p:spTree>
     <p:extLst>
       <p:ext uri="{BB962C8B-B14F-4D97-AF65-F5344CB8AC3E}">
@@ -8277,6 +8246,36 @@
           <a:chExt cx="0" cy="0"/>
         </a:xfrm>
       </p:grpSpPr>
+      <p:pic>
+        <p:nvPicPr>
+          <p:cNvPr id="7" name="Picture 6">
+            <a:extLst>
+              <a:ext uri="{FF2B5EF4-FFF2-40B4-BE49-F238E27FC236}">
+                <a16:creationId xmlns:a16="http://schemas.microsoft.com/office/drawing/2014/main" id="{6CBA3C59-9D86-68AE-5F26-96C922E82678}"/>
+              </a:ext>
+            </a:extLst>
+          </p:cNvPr>
+          <p:cNvPicPr>
+            <a:picLocks noChangeAspect="1"/>
+          </p:cNvPicPr>
+          <p:nvPr/>
+        </p:nvPicPr>
+        <p:blipFill>
+          <a:blip r:embed="rId2"/>
+          <a:stretch>
+            <a:fillRect/>
+          </a:stretch>
+        </p:blipFill>
+        <p:spPr>
+          <a:xfrm>
+            <a:off x="1472618" y="352308"/>
+            <a:ext cx="6326505" cy="2811780"/>
+          </a:xfrm>
+          <a:prstGeom prst="rect">
+            <a:avLst/>
+          </a:prstGeom>
+        </p:spPr>
+      </p:pic>
       <p:sp>
         <p:nvSpPr>
           <p:cNvPr id="10" name="TextBox 9">
@@ -8320,36 +8319,6 @@
           </a:p>
         </p:txBody>
       </p:sp>
-      <p:pic>
-        <p:nvPicPr>
-          <p:cNvPr id="18" name="Picture 17">
-            <a:extLst>
-              <a:ext uri="{FF2B5EF4-FFF2-40B4-BE49-F238E27FC236}">
-                <a16:creationId xmlns:a16="http://schemas.microsoft.com/office/drawing/2014/main" id="{E94B7A5B-C913-F31C-05F5-7BF25A18110F}"/>
-              </a:ext>
-            </a:extLst>
-          </p:cNvPr>
-          <p:cNvPicPr>
-            <a:picLocks noChangeAspect="1"/>
-          </p:cNvPicPr>
-          <p:nvPr/>
-        </p:nvPicPr>
-        <p:blipFill>
-          <a:blip r:embed="rId2"/>
-          <a:stretch>
-            <a:fillRect/>
-          </a:stretch>
-        </p:blipFill>
-        <p:spPr>
-          <a:xfrm>
-            <a:off x="1456843" y="265668"/>
-            <a:ext cx="6457951" cy="2870200"/>
-          </a:xfrm>
-          <a:prstGeom prst="rect">
-            <a:avLst/>
-          </a:prstGeom>
-        </p:spPr>
-      </p:pic>
       <p:pic>
         <p:nvPicPr>
           <p:cNvPr id="36" name="Picture 35">
@@ -8449,7 +8418,7 @@
               <a:t>b) </a:t>
             </a:r>
             <a:r>
-              <a:rPr lang="en-US" sz="1200" dirty="0" err="1"/>
+              <a:rPr lang="en-US" sz="1200" dirty="0"/>
               <a:t>SINDy</a:t>
             </a:r>
             <a:endParaRPr lang="en-US" sz="1200" b="1" dirty="0"/>
@@ -8780,8 +8749,8 @@
         </p:nvSpPr>
         <p:spPr>
           <a:xfrm>
-            <a:off x="1456841" y="4389363"/>
-            <a:ext cx="1240060" cy="276999"/>
+            <a:off x="1456840" y="4389363"/>
+            <a:ext cx="1363067" cy="276999"/>
           </a:xfrm>
           <a:prstGeom prst="rect">
             <a:avLst/>
@@ -8800,7 +8769,7 @@
             </a:r>
             <a:r>
               <a:rPr lang="en-US" sz="1200" dirty="0"/>
-              <a:t>NN-driven*</a:t>
+              <a:t>NN-derivative*</a:t>
             </a:r>
             <a:endParaRPr lang="en-US" sz="1200" b="1" dirty="0"/>
           </a:p>
@@ -8978,246 +8947,6 @@
   <p:cSld>
     <p:spTree>
       <p:nvGrpSpPr>
-        <p:cNvPr id="1" name=""/>
-        <p:cNvGrpSpPr/>
-        <p:nvPr/>
-      </p:nvGrpSpPr>
-      <p:grpSpPr>
-        <a:xfrm>
-          <a:off x="0" y="0"/>
-          <a:ext cx="0" cy="0"/>
-          <a:chOff x="0" y="0"/>
-          <a:chExt cx="0" cy="0"/>
-        </a:xfrm>
-      </p:grpSpPr>
-      <p:pic>
-        <p:nvPicPr>
-          <p:cNvPr id="5" name="Picture 4">
-            <a:extLst>
-              <a:ext uri="{FF2B5EF4-FFF2-40B4-BE49-F238E27FC236}">
-                <a16:creationId xmlns:a16="http://schemas.microsoft.com/office/drawing/2014/main" id="{EF9474AD-595A-EBD1-4D17-4E6912AEB38C}"/>
-              </a:ext>
-            </a:extLst>
-          </p:cNvPr>
-          <p:cNvPicPr>
-            <a:picLocks noChangeAspect="1"/>
-          </p:cNvPicPr>
-          <p:nvPr/>
-        </p:nvPicPr>
-        <p:blipFill>
-          <a:blip r:embed="rId2"/>
-          <a:stretch>
-            <a:fillRect/>
-          </a:stretch>
-        </p:blipFill>
-        <p:spPr>
-          <a:xfrm>
-            <a:off x="2545492" y="408830"/>
-            <a:ext cx="4085967" cy="2042984"/>
-          </a:xfrm>
-          <a:prstGeom prst="rect">
-            <a:avLst/>
-          </a:prstGeom>
-        </p:spPr>
-      </p:pic>
-      <p:sp>
-        <p:nvSpPr>
-          <p:cNvPr id="6" name="TextBox 5">
-            <a:extLst>
-              <a:ext uri="{FF2B5EF4-FFF2-40B4-BE49-F238E27FC236}">
-                <a16:creationId xmlns:a16="http://schemas.microsoft.com/office/drawing/2014/main" id="{3943EFA6-50E9-CEBE-D1B3-97626D1A6C08}"/>
-              </a:ext>
-            </a:extLst>
-          </p:cNvPr>
-          <p:cNvSpPr txBox="1"/>
-          <p:nvPr/>
-        </p:nvSpPr>
-        <p:spPr>
-          <a:xfrm>
-            <a:off x="2534657" y="290440"/>
-            <a:ext cx="1013798" cy="261610"/>
-          </a:xfrm>
-          <a:prstGeom prst="rect">
-            <a:avLst/>
-          </a:prstGeom>
-          <a:noFill/>
-        </p:spPr>
-        <p:txBody>
-          <a:bodyPr wrap="square" rtlCol="0">
-            <a:spAutoFit/>
-          </a:bodyPr>
-          <a:lstStyle/>
-          <a:p>
-            <a:r>
-              <a:rPr lang="en-US" sz="1100" b="1" dirty="0"/>
-              <a:t>a) </a:t>
-            </a:r>
-            <a:r>
-              <a:rPr lang="en-US" sz="1100" dirty="0" err="1"/>
-              <a:t>SINDy</a:t>
-            </a:r>
-            <a:endParaRPr lang="en-US" sz="1100" b="1" dirty="0"/>
-          </a:p>
-        </p:txBody>
-      </p:sp>
-      <p:pic>
-        <p:nvPicPr>
-          <p:cNvPr id="10" name="Picture 9">
-            <a:extLst>
-              <a:ext uri="{FF2B5EF4-FFF2-40B4-BE49-F238E27FC236}">
-                <a16:creationId xmlns:a16="http://schemas.microsoft.com/office/drawing/2014/main" id="{20655E92-A156-DBB2-48DD-2433901556F7}"/>
-              </a:ext>
-            </a:extLst>
-          </p:cNvPr>
-          <p:cNvPicPr>
-            <a:picLocks noChangeAspect="1"/>
-          </p:cNvPicPr>
-          <p:nvPr/>
-        </p:nvPicPr>
-        <p:blipFill>
-          <a:blip r:embed="rId3"/>
-          <a:stretch>
-            <a:fillRect/>
-          </a:stretch>
-        </p:blipFill>
-        <p:spPr>
-          <a:xfrm>
-            <a:off x="2545492" y="2582619"/>
-            <a:ext cx="4085967" cy="2042984"/>
-          </a:xfrm>
-          <a:prstGeom prst="rect">
-            <a:avLst/>
-          </a:prstGeom>
-        </p:spPr>
-      </p:pic>
-      <p:sp>
-        <p:nvSpPr>
-          <p:cNvPr id="11" name="TextBox 10">
-            <a:extLst>
-              <a:ext uri="{FF2B5EF4-FFF2-40B4-BE49-F238E27FC236}">
-                <a16:creationId xmlns:a16="http://schemas.microsoft.com/office/drawing/2014/main" id="{0E7B52B4-01D8-0898-7E41-8B0419FB3EE4}"/>
-              </a:ext>
-            </a:extLst>
-          </p:cNvPr>
-          <p:cNvSpPr txBox="1"/>
-          <p:nvPr/>
-        </p:nvSpPr>
-        <p:spPr>
-          <a:xfrm>
-            <a:off x="2457473" y="2486139"/>
-            <a:ext cx="1240060" cy="261610"/>
-          </a:xfrm>
-          <a:prstGeom prst="rect">
-            <a:avLst/>
-          </a:prstGeom>
-          <a:noFill/>
-        </p:spPr>
-        <p:txBody>
-          <a:bodyPr wrap="square" rtlCol="0">
-            <a:spAutoFit/>
-          </a:bodyPr>
-          <a:lstStyle/>
-          <a:p>
-            <a:r>
-              <a:rPr lang="en-US" sz="1100" b="1" dirty="0"/>
-              <a:t>b) </a:t>
-            </a:r>
-            <a:r>
-              <a:rPr lang="en-US" sz="1100" dirty="0"/>
-              <a:t>NN-driven</a:t>
-            </a:r>
-            <a:endParaRPr lang="en-US" sz="1100" b="1" dirty="0"/>
-          </a:p>
-        </p:txBody>
-      </p:sp>
-      <p:pic>
-        <p:nvPicPr>
-          <p:cNvPr id="13" name="Picture 12">
-            <a:extLst>
-              <a:ext uri="{FF2B5EF4-FFF2-40B4-BE49-F238E27FC236}">
-                <a16:creationId xmlns:a16="http://schemas.microsoft.com/office/drawing/2014/main" id="{74AB1E86-D1E8-833F-D3A9-6D08ED0F85E9}"/>
-              </a:ext>
-            </a:extLst>
-          </p:cNvPr>
-          <p:cNvPicPr>
-            <a:picLocks noChangeAspect="1"/>
-          </p:cNvPicPr>
-          <p:nvPr/>
-        </p:nvPicPr>
-        <p:blipFill>
-          <a:blip r:embed="rId4"/>
-          <a:stretch>
-            <a:fillRect/>
-          </a:stretch>
-        </p:blipFill>
-        <p:spPr>
-          <a:xfrm>
-            <a:off x="2534657" y="4691507"/>
-            <a:ext cx="4085968" cy="2042984"/>
-          </a:xfrm>
-          <a:prstGeom prst="rect">
-            <a:avLst/>
-          </a:prstGeom>
-        </p:spPr>
-      </p:pic>
-      <p:sp>
-        <p:nvSpPr>
-          <p:cNvPr id="14" name="TextBox 13">
-            <a:extLst>
-              <a:ext uri="{FF2B5EF4-FFF2-40B4-BE49-F238E27FC236}">
-                <a16:creationId xmlns:a16="http://schemas.microsoft.com/office/drawing/2014/main" id="{1BC1A71A-BE91-75CF-E81F-7AD88F0EFF75}"/>
-              </a:ext>
-            </a:extLst>
-          </p:cNvPr>
-          <p:cNvSpPr txBox="1"/>
-          <p:nvPr/>
-        </p:nvSpPr>
-        <p:spPr>
-          <a:xfrm>
-            <a:off x="2545492" y="4596400"/>
-            <a:ext cx="841709" cy="261610"/>
-          </a:xfrm>
-          <a:prstGeom prst="rect">
-            <a:avLst/>
-          </a:prstGeom>
-          <a:noFill/>
-        </p:spPr>
-        <p:txBody>
-          <a:bodyPr wrap="square" rtlCol="0">
-            <a:spAutoFit/>
-          </a:bodyPr>
-          <a:lstStyle/>
-          <a:p>
-            <a:r>
-              <a:rPr lang="en-US" sz="1100" b="1" dirty="0"/>
-              <a:t>c) </a:t>
-            </a:r>
-            <a:r>
-              <a:rPr lang="en-US" sz="1100" dirty="0"/>
-              <a:t>AR</a:t>
-            </a:r>
-            <a:endParaRPr lang="en-US" sz="1100" b="1" dirty="0"/>
-          </a:p>
-        </p:txBody>
-      </p:sp>
-    </p:spTree>
-    <p:extLst>
-      <p:ext uri="{BB962C8B-B14F-4D97-AF65-F5344CB8AC3E}">
-        <p14:creationId xmlns:p14="http://schemas.microsoft.com/office/powerpoint/2010/main" val="1736462962"/>
-      </p:ext>
-    </p:extLst>
-  </p:cSld>
-  <p:clrMapOvr>
-    <a:masterClrMapping/>
-  </p:clrMapOvr>
-</p:sld>
-</file>
-
-<file path=ppt/slides/slide6.xml><?xml version="1.0" encoding="utf-8"?>
-<p:sld xmlns:a="http://schemas.openxmlformats.org/drawingml/2006/main" xmlns:r="http://schemas.openxmlformats.org/officeDocument/2006/relationships" xmlns:p="http://schemas.openxmlformats.org/presentationml/2006/main">
-  <p:cSld>
-    <p:spTree>
-      <p:nvGrpSpPr>
         <p:cNvPr id="1" name="">
           <a:extLst>
             <a:ext uri="{FF2B5EF4-FFF2-40B4-BE49-F238E27FC236}">
@@ -9238,10 +8967,10 @@
       </p:grpSpPr>
       <p:pic>
         <p:nvPicPr>
-          <p:cNvPr id="3" name="Picture 2">
-            <a:extLst>
-              <a:ext uri="{FF2B5EF4-FFF2-40B4-BE49-F238E27FC236}">
-                <a16:creationId xmlns:a16="http://schemas.microsoft.com/office/drawing/2014/main" id="{98F1A68F-3818-B41E-CE5F-3A2CD714ACA6}"/>
+          <p:cNvPr id="12" name="Picture 11">
+            <a:extLst>
+              <a:ext uri="{FF2B5EF4-FFF2-40B4-BE49-F238E27FC236}">
+                <a16:creationId xmlns:a16="http://schemas.microsoft.com/office/drawing/2014/main" id="{3B0EDECF-1C9C-797C-64FA-97B0B50AAA30}"/>
               </a:ext>
             </a:extLst>
           </p:cNvPr>
@@ -9258,8 +8987,8 @@
         </p:blipFill>
         <p:spPr>
           <a:xfrm>
-            <a:off x="2534657" y="4593449"/>
-            <a:ext cx="4493937" cy="2246969"/>
+            <a:off x="2534654" y="4586805"/>
+            <a:ext cx="4493940" cy="2246970"/>
           </a:xfrm>
           <a:prstGeom prst="rect">
             <a:avLst/>
@@ -9268,10 +8997,10 @@
       </p:pic>
       <p:pic>
         <p:nvPicPr>
-          <p:cNvPr id="7" name="Picture 6">
-            <a:extLst>
-              <a:ext uri="{FF2B5EF4-FFF2-40B4-BE49-F238E27FC236}">
-                <a16:creationId xmlns:a16="http://schemas.microsoft.com/office/drawing/2014/main" id="{930F7D46-E8B9-8B38-B113-97E201573CC2}"/>
+          <p:cNvPr id="4" name="Picture 3">
+            <a:extLst>
+              <a:ext uri="{FF2B5EF4-FFF2-40B4-BE49-F238E27FC236}">
+                <a16:creationId xmlns:a16="http://schemas.microsoft.com/office/drawing/2014/main" id="{31EFFF37-7AD6-C6C2-E20D-198CFAFD4C7B}"/>
               </a:ext>
             </a:extLst>
           </p:cNvPr>
@@ -9288,8 +9017,8 @@
         </p:blipFill>
         <p:spPr>
           <a:xfrm>
-            <a:off x="2545492" y="290440"/>
-            <a:ext cx="4493937" cy="2246969"/>
+            <a:off x="2534656" y="292110"/>
+            <a:ext cx="4493938" cy="2246969"/>
           </a:xfrm>
           <a:prstGeom prst="rect">
             <a:avLst/>
@@ -9298,10 +9027,10 @@
       </p:pic>
       <p:pic>
         <p:nvPicPr>
-          <p:cNvPr id="9" name="Picture 8">
-            <a:extLst>
-              <a:ext uri="{FF2B5EF4-FFF2-40B4-BE49-F238E27FC236}">
-                <a16:creationId xmlns:a16="http://schemas.microsoft.com/office/drawing/2014/main" id="{84392866-86A5-2DC9-74F1-367B16EDCD46}"/>
+          <p:cNvPr id="8" name="Picture 7">
+            <a:extLst>
+              <a:ext uri="{FF2B5EF4-FFF2-40B4-BE49-F238E27FC236}">
+                <a16:creationId xmlns:a16="http://schemas.microsoft.com/office/drawing/2014/main" id="{9336BABA-3263-308B-55C4-F3117C52DA78}"/>
               </a:ext>
             </a:extLst>
           </p:cNvPr>
@@ -9318,7 +9047,7 @@
         </p:blipFill>
         <p:spPr>
           <a:xfrm>
-            <a:off x="2545492" y="2480236"/>
+            <a:off x="2534656" y="2464656"/>
             <a:ext cx="4493938" cy="2246969"/>
           </a:xfrm>
           <a:prstGeom prst="rect">
@@ -9359,7 +9088,7 @@
               <a:t>a) </a:t>
             </a:r>
             <a:r>
-              <a:rPr lang="en-US" sz="1100" dirty="0" err="1"/>
+              <a:rPr lang="en-US" sz="1100" dirty="0"/>
               <a:t>SINDy</a:t>
             </a:r>
             <a:endParaRPr lang="en-US" sz="1100" b="1" dirty="0"/>
@@ -9380,7 +9109,7 @@
         </p:nvSpPr>
         <p:spPr>
           <a:xfrm>
-            <a:off x="2457473" y="2486139"/>
+            <a:off x="2534654" y="2474250"/>
             <a:ext cx="1240060" cy="261610"/>
           </a:xfrm>
           <a:prstGeom prst="rect">
@@ -9400,7 +9129,7 @@
             </a:r>
             <a:r>
               <a:rPr lang="en-US" sz="1100" dirty="0"/>
-              <a:t>NN-driven</a:t>
+              <a:t>NN-derivative</a:t>
             </a:r>
             <a:endParaRPr lang="en-US" sz="1100" b="1" dirty="0"/>
           </a:p>
@@ -9459,7 +9188,7 @@
 </p:sld>
 </file>
 
-<file path=ppt/slides/slide7.xml><?xml version="1.0" encoding="utf-8"?>
+<file path=ppt/slides/slide6.xml><?xml version="1.0" encoding="utf-8"?>
 <p:sld xmlns:a="http://schemas.openxmlformats.org/drawingml/2006/main" xmlns:r="http://schemas.openxmlformats.org/officeDocument/2006/relationships" xmlns:p="http://schemas.openxmlformats.org/presentationml/2006/main">
   <p:cSld>
     <p:spTree>
@@ -9484,10 +9213,10 @@
       </p:grpSpPr>
       <p:pic>
         <p:nvPicPr>
-          <p:cNvPr id="18" name="Picture 17">
-            <a:extLst>
-              <a:ext uri="{FF2B5EF4-FFF2-40B4-BE49-F238E27FC236}">
-                <a16:creationId xmlns:a16="http://schemas.microsoft.com/office/drawing/2014/main" id="{DAA82645-09CB-B803-B916-9EB17C399C9B}"/>
+          <p:cNvPr id="24" name="Picture 23">
+            <a:extLst>
+              <a:ext uri="{FF2B5EF4-FFF2-40B4-BE49-F238E27FC236}">
+                <a16:creationId xmlns:a16="http://schemas.microsoft.com/office/drawing/2014/main" id="{89E35905-3C3D-C297-B4C9-829CF7CFBB90}"/>
               </a:ext>
             </a:extLst>
           </p:cNvPr>
@@ -9498,15 +9227,14 @@
         </p:nvPicPr>
         <p:blipFill>
           <a:blip r:embed="rId2"/>
-          <a:srcRect t="42026" b="33007"/>
           <a:stretch>
             <a:fillRect/>
           </a:stretch>
         </p:blipFill>
         <p:spPr>
           <a:xfrm>
-            <a:off x="1410755" y="5685184"/>
-            <a:ext cx="6550336" cy="981249"/>
+            <a:off x="1362909" y="36090"/>
+            <a:ext cx="6557220" cy="3278610"/>
           </a:xfrm>
           <a:prstGeom prst="rect">
             <a:avLst/>
@@ -9515,10 +9243,10 @@
       </p:pic>
       <p:pic>
         <p:nvPicPr>
-          <p:cNvPr id="8" name="Picture 7">
-            <a:extLst>
-              <a:ext uri="{FF2B5EF4-FFF2-40B4-BE49-F238E27FC236}">
-                <a16:creationId xmlns:a16="http://schemas.microsoft.com/office/drawing/2014/main" id="{88F8CDB0-6A4E-9F02-7527-865679F6B129}"/>
+          <p:cNvPr id="18" name="Picture 17">
+            <a:extLst>
+              <a:ext uri="{FF2B5EF4-FFF2-40B4-BE49-F238E27FC236}">
+                <a16:creationId xmlns:a16="http://schemas.microsoft.com/office/drawing/2014/main" id="{DAA82645-09CB-B803-B916-9EB17C399C9B}"/>
               </a:ext>
             </a:extLst>
           </p:cNvPr>
@@ -9529,14 +9257,15 @@
         </p:nvPicPr>
         <p:blipFill>
           <a:blip r:embed="rId3"/>
+          <a:srcRect t="42026" b="33007"/>
           <a:stretch>
             <a:fillRect/>
           </a:stretch>
         </p:blipFill>
         <p:spPr>
           <a:xfrm>
-            <a:off x="1663039" y="143306"/>
-            <a:ext cx="6054497" cy="3027249"/>
+            <a:off x="1410755" y="5791514"/>
+            <a:ext cx="6550336" cy="981249"/>
           </a:xfrm>
           <a:prstGeom prst="rect">
             <a:avLst/>
@@ -9600,7 +9329,7 @@
         </p:nvSpPr>
         <p:spPr>
           <a:xfrm>
-            <a:off x="1456843" y="265668"/>
+            <a:off x="1456841" y="173335"/>
             <a:ext cx="841709" cy="276999"/>
           </a:xfrm>
           <a:prstGeom prst="rect">
@@ -9635,7 +9364,7 @@
         </p:nvSpPr>
         <p:spPr>
           <a:xfrm>
-            <a:off x="1472618" y="3121223"/>
+            <a:off x="1472618" y="3227553"/>
             <a:ext cx="1013798" cy="276999"/>
           </a:xfrm>
           <a:prstGeom prst="rect">
@@ -9654,7 +9383,7 @@
               <a:t>b) </a:t>
             </a:r>
             <a:r>
-              <a:rPr lang="en-US" sz="1200" dirty="0" err="1"/>
+              <a:rPr lang="en-US" sz="1200" dirty="0"/>
               <a:t>SINDy</a:t>
             </a:r>
             <a:endParaRPr lang="en-US" sz="1200" b="1" dirty="0"/>
@@ -9675,8 +9404,8 @@
         </p:nvSpPr>
         <p:spPr>
           <a:xfrm>
-            <a:off x="1456841" y="4389363"/>
-            <a:ext cx="1240060" cy="276999"/>
+            <a:off x="1456840" y="4495693"/>
+            <a:ext cx="1358839" cy="276999"/>
           </a:xfrm>
           <a:prstGeom prst="rect">
             <a:avLst/>
@@ -9695,7 +9424,7 @@
             </a:r>
             <a:r>
               <a:rPr lang="en-US" sz="1200" dirty="0"/>
-              <a:t>NN-driven</a:t>
+              <a:t>NN-derivative</a:t>
             </a:r>
             <a:endParaRPr lang="en-US" sz="1200" b="1" dirty="0"/>
           </a:p>
@@ -9715,7 +9444,7 @@
         </p:nvSpPr>
         <p:spPr>
           <a:xfrm>
-            <a:off x="1456841" y="5460003"/>
+            <a:off x="1456841" y="5566333"/>
             <a:ext cx="841709" cy="276999"/>
           </a:xfrm>
           <a:prstGeom prst="rect">
@@ -9764,7 +9493,7 @@
         </p:blipFill>
         <p:spPr>
           <a:xfrm>
-            <a:off x="1419874" y="4611850"/>
+            <a:off x="1419874" y="4718180"/>
             <a:ext cx="6541216" cy="848153"/>
           </a:xfrm>
           <a:prstGeom prst="rect">
@@ -9786,7 +9515,7 @@
         </p:nvSpPr>
         <p:spPr>
           <a:xfrm>
-            <a:off x="6954792" y="6472393"/>
+            <a:off x="6954792" y="6578723"/>
             <a:ext cx="704486" cy="261610"/>
           </a:xfrm>
           <a:prstGeom prst="rect">
@@ -9821,7 +9550,7 @@
         </p:nvSpPr>
         <p:spPr>
           <a:xfrm>
-            <a:off x="2499926" y="6475530"/>
+            <a:off x="2499926" y="6581860"/>
             <a:ext cx="704486" cy="261610"/>
           </a:xfrm>
           <a:prstGeom prst="rect">
@@ -9856,7 +9585,7 @@
         </p:nvSpPr>
         <p:spPr>
           <a:xfrm>
-            <a:off x="5621327" y="6494979"/>
+            <a:off x="5621327" y="6601309"/>
             <a:ext cx="459331" cy="261610"/>
           </a:xfrm>
           <a:prstGeom prst="rect">
@@ -9891,7 +9620,7 @@
         </p:nvSpPr>
         <p:spPr>
           <a:xfrm>
-            <a:off x="2852169" y="6482920"/>
+            <a:off x="2852169" y="6589250"/>
             <a:ext cx="704486" cy="261610"/>
           </a:xfrm>
           <a:prstGeom prst="rect">
@@ -9926,7 +9655,7 @@
         </p:nvGrpSpPr>
         <p:grpSpPr>
           <a:xfrm>
-            <a:off x="1419874" y="3121223"/>
+            <a:off x="1419874" y="3227553"/>
             <a:ext cx="6541216" cy="3398903"/>
             <a:chOff x="1419874" y="3121223"/>
             <a:chExt cx="6541216" cy="3398903"/>
@@ -10128,7 +9857,7 @@
         </p:nvSpPr>
         <p:spPr>
           <a:xfrm>
-            <a:off x="3813717" y="3097658"/>
+            <a:off x="3813717" y="3203988"/>
             <a:ext cx="1991557" cy="128762"/>
           </a:xfrm>
           <a:prstGeom prst="rect">
@@ -10189,7 +9918,7 @@
         </p:blipFill>
         <p:spPr>
           <a:xfrm>
-            <a:off x="4435431" y="3114575"/>
+            <a:off x="4435431" y="3220905"/>
             <a:ext cx="1013798" cy="128762"/>
           </a:xfrm>
           <a:prstGeom prst="rect">
@@ -10211,7 +9940,7 @@
         </p:nvSpPr>
         <p:spPr>
           <a:xfrm>
-            <a:off x="2966262" y="3665285"/>
+            <a:off x="2966262" y="3771615"/>
             <a:ext cx="45719" cy="2872758"/>
           </a:xfrm>
           <a:prstGeom prst="rect">
@@ -10265,7 +9994,7 @@
         </p:nvSpPr>
         <p:spPr>
           <a:xfrm>
-            <a:off x="5805273" y="3647668"/>
+            <a:off x="5805273" y="3753998"/>
             <a:ext cx="45719" cy="2872758"/>
           </a:xfrm>
           <a:prstGeom prst="rect">
@@ -10319,7 +10048,7 @@
         </p:nvSpPr>
         <p:spPr>
           <a:xfrm>
-            <a:off x="1472618" y="3241257"/>
+            <a:off x="1472618" y="3347587"/>
             <a:ext cx="1240060" cy="276999"/>
           </a:xfrm>
           <a:prstGeom prst="rect">
@@ -10338,7 +10067,7 @@
               <a:t>b) </a:t>
             </a:r>
             <a:r>
-              <a:rPr lang="en-US" sz="1200" dirty="0" err="1"/>
+              <a:rPr lang="en-US" sz="1200" dirty="0"/>
               <a:t>SINDy</a:t>
             </a:r>
             <a:endParaRPr lang="en-US" sz="1200" b="1" dirty="0"/>
@@ -10359,7 +10088,7 @@
         </p:nvGrpSpPr>
         <p:grpSpPr>
           <a:xfrm>
-            <a:off x="7084684" y="3640137"/>
+            <a:off x="7084684" y="3746467"/>
             <a:ext cx="54232" cy="2854842"/>
             <a:chOff x="6646426" y="3652754"/>
             <a:chExt cx="54232" cy="2854842"/>

</xml_diff>

<commit_message>
update a few figs
</commit_message>
<xml_diff>
--- a/figures/figures.pptx
+++ b/figures/figures.pptx
@@ -11,6 +11,7 @@
     <p:sldId id="266" r:id="rId5"/>
     <p:sldId id="269" r:id="rId6"/>
     <p:sldId id="268" r:id="rId7"/>
+    <p:sldId id="270" r:id="rId8"/>
   </p:sldIdLst>
   <p:sldSz cx="12192000" cy="6858000"/>
   <p:notesSz cx="6858000" cy="9144000"/>
@@ -9924,6 +9925,238 @@
 </p:sld>
 </file>
 
+<file path=ppt/slides/slide7.xml><?xml version="1.0" encoding="utf-8"?>
+<p:sld xmlns:a="http://schemas.openxmlformats.org/drawingml/2006/main" xmlns:r="http://schemas.openxmlformats.org/officeDocument/2006/relationships" xmlns:p="http://schemas.openxmlformats.org/presentationml/2006/main">
+  <p:cSld>
+    <p:spTree>
+      <p:nvGrpSpPr>
+        <p:cNvPr id="1" name=""/>
+        <p:cNvGrpSpPr/>
+        <p:nvPr/>
+      </p:nvGrpSpPr>
+      <p:grpSpPr>
+        <a:xfrm>
+          <a:off x="0" y="0"/>
+          <a:ext cx="0" cy="0"/>
+          <a:chOff x="0" y="0"/>
+          <a:chExt cx="0" cy="0"/>
+        </a:xfrm>
+      </p:grpSpPr>
+      <p:pic>
+        <p:nvPicPr>
+          <p:cNvPr id="11" name="Picture 10">
+            <a:extLst>
+              <a:ext uri="{FF2B5EF4-FFF2-40B4-BE49-F238E27FC236}">
+                <a16:creationId xmlns:a16="http://schemas.microsoft.com/office/drawing/2014/main" id="{FED8DAA8-D68D-BED5-7B0A-67B3D0363FF2}"/>
+              </a:ext>
+            </a:extLst>
+          </p:cNvPr>
+          <p:cNvPicPr>
+            <a:picLocks noChangeAspect="1"/>
+          </p:cNvPicPr>
+          <p:nvPr/>
+        </p:nvPicPr>
+        <p:blipFill>
+          <a:blip r:embed="rId2"/>
+          <a:stretch>
+            <a:fillRect/>
+          </a:stretch>
+        </p:blipFill>
+        <p:spPr>
+          <a:xfrm>
+            <a:off x="2529169" y="1055451"/>
+            <a:ext cx="6972300" cy="4673600"/>
+          </a:xfrm>
+          <a:prstGeom prst="rect">
+            <a:avLst/>
+          </a:prstGeom>
+        </p:spPr>
+      </p:pic>
+      <p:sp>
+        <p:nvSpPr>
+          <p:cNvPr id="6" name="TextBox 5">
+            <a:extLst>
+              <a:ext uri="{FF2B5EF4-FFF2-40B4-BE49-F238E27FC236}">
+                <a16:creationId xmlns:a16="http://schemas.microsoft.com/office/drawing/2014/main" id="{189D26E9-2E4A-CD93-F4AF-15BB9CD2C711}"/>
+              </a:ext>
+            </a:extLst>
+          </p:cNvPr>
+          <p:cNvSpPr txBox="1"/>
+          <p:nvPr/>
+        </p:nvSpPr>
+        <p:spPr>
+          <a:xfrm>
+            <a:off x="2662520" y="907534"/>
+            <a:ext cx="484094" cy="338554"/>
+          </a:xfrm>
+          <a:prstGeom prst="rect">
+            <a:avLst/>
+          </a:prstGeom>
+          <a:noFill/>
+        </p:spPr>
+        <p:txBody>
+          <a:bodyPr wrap="square" rtlCol="0">
+            <a:spAutoFit/>
+          </a:bodyPr>
+          <a:lstStyle/>
+          <a:p>
+            <a:r>
+              <a:rPr lang="en-US" sz="1600" dirty="0"/>
+              <a:t>a)</a:t>
+            </a:r>
+          </a:p>
+        </p:txBody>
+      </p:sp>
+      <p:sp>
+        <p:nvSpPr>
+          <p:cNvPr id="7" name="TextBox 6">
+            <a:extLst>
+              <a:ext uri="{FF2B5EF4-FFF2-40B4-BE49-F238E27FC236}">
+                <a16:creationId xmlns:a16="http://schemas.microsoft.com/office/drawing/2014/main" id="{465E3ABF-F07F-AFEB-0BE9-0CA32E0238F0}"/>
+              </a:ext>
+            </a:extLst>
+          </p:cNvPr>
+          <p:cNvSpPr txBox="1"/>
+          <p:nvPr/>
+        </p:nvSpPr>
+        <p:spPr>
+          <a:xfrm>
+            <a:off x="5449983" y="907534"/>
+            <a:ext cx="484094" cy="338554"/>
+          </a:xfrm>
+          <a:prstGeom prst="rect">
+            <a:avLst/>
+          </a:prstGeom>
+          <a:noFill/>
+        </p:spPr>
+        <p:txBody>
+          <a:bodyPr wrap="square" rtlCol="0">
+            <a:spAutoFit/>
+          </a:bodyPr>
+          <a:lstStyle/>
+          <a:p>
+            <a:r>
+              <a:rPr lang="en-US" sz="1600" dirty="0"/>
+              <a:t>b)</a:t>
+            </a:r>
+          </a:p>
+        </p:txBody>
+      </p:sp>
+      <p:sp>
+        <p:nvSpPr>
+          <p:cNvPr id="8" name="TextBox 7">
+            <a:extLst>
+              <a:ext uri="{FF2B5EF4-FFF2-40B4-BE49-F238E27FC236}">
+                <a16:creationId xmlns:a16="http://schemas.microsoft.com/office/drawing/2014/main" id="{F2176287-B47D-E6D0-46EE-A262F3573726}"/>
+              </a:ext>
+            </a:extLst>
+          </p:cNvPr>
+          <p:cNvSpPr txBox="1"/>
+          <p:nvPr/>
+        </p:nvSpPr>
+        <p:spPr>
+          <a:xfrm>
+            <a:off x="2635626" y="3296326"/>
+            <a:ext cx="484094" cy="338554"/>
+          </a:xfrm>
+          <a:prstGeom prst="rect">
+            <a:avLst/>
+          </a:prstGeom>
+          <a:noFill/>
+        </p:spPr>
+        <p:txBody>
+          <a:bodyPr wrap="square" rtlCol="0">
+            <a:spAutoFit/>
+          </a:bodyPr>
+          <a:lstStyle/>
+          <a:p>
+            <a:r>
+              <a:rPr lang="en-US" sz="1600" dirty="0"/>
+              <a:t>c)</a:t>
+            </a:r>
+          </a:p>
+        </p:txBody>
+      </p:sp>
+      <p:sp>
+        <p:nvSpPr>
+          <p:cNvPr id="9" name="TextBox 8">
+            <a:extLst>
+              <a:ext uri="{FF2B5EF4-FFF2-40B4-BE49-F238E27FC236}">
+                <a16:creationId xmlns:a16="http://schemas.microsoft.com/office/drawing/2014/main" id="{859B76DB-2B1B-FBE0-87A2-A13B06AFC064}"/>
+              </a:ext>
+            </a:extLst>
+          </p:cNvPr>
+          <p:cNvSpPr txBox="1"/>
+          <p:nvPr/>
+        </p:nvSpPr>
+        <p:spPr>
+          <a:xfrm>
+            <a:off x="5423649" y="3296326"/>
+            <a:ext cx="484094" cy="338554"/>
+          </a:xfrm>
+          <a:prstGeom prst="rect">
+            <a:avLst/>
+          </a:prstGeom>
+          <a:noFill/>
+        </p:spPr>
+        <p:txBody>
+          <a:bodyPr wrap="square" rtlCol="0">
+            <a:spAutoFit/>
+          </a:bodyPr>
+          <a:lstStyle/>
+          <a:p>
+            <a:r>
+              <a:rPr lang="en-US" sz="1600" dirty="0"/>
+              <a:t>d)</a:t>
+            </a:r>
+          </a:p>
+        </p:txBody>
+      </p:sp>
+      <p:sp>
+        <p:nvSpPr>
+          <p:cNvPr id="12" name="TextBox 11">
+            <a:extLst>
+              <a:ext uri="{FF2B5EF4-FFF2-40B4-BE49-F238E27FC236}">
+                <a16:creationId xmlns:a16="http://schemas.microsoft.com/office/drawing/2014/main" id="{41FC3D2A-DF4F-DB7A-8DE5-FCB5A316A3E2}"/>
+              </a:ext>
+            </a:extLst>
+          </p:cNvPr>
+          <p:cNvSpPr txBox="1"/>
+          <p:nvPr/>
+        </p:nvSpPr>
+        <p:spPr>
+          <a:xfrm>
+            <a:off x="11430000" y="2864224"/>
+            <a:ext cx="184731" cy="369332"/>
+          </a:xfrm>
+          <a:prstGeom prst="rect">
+            <a:avLst/>
+          </a:prstGeom>
+          <a:noFill/>
+        </p:spPr>
+        <p:txBody>
+          <a:bodyPr wrap="none" rtlCol="0">
+            <a:spAutoFit/>
+          </a:bodyPr>
+          <a:lstStyle/>
+          <a:p>
+            <a:endParaRPr lang="en-US"/>
+          </a:p>
+        </p:txBody>
+      </p:sp>
+    </p:spTree>
+    <p:extLst>
+      <p:ext uri="{BB962C8B-B14F-4D97-AF65-F5344CB8AC3E}">
+        <p14:creationId xmlns:p14="http://schemas.microsoft.com/office/powerpoint/2010/main" val="1815007270"/>
+      </p:ext>
+    </p:extLst>
+  </p:cSld>
+  <p:clrMapOvr>
+    <a:masterClrMapping/>
+  </p:clrMapOvr>
+</p:sld>
+</file>
+
 <file path=ppt/theme/theme1.xml><?xml version="1.0" encoding="utf-8"?>
 <a:theme xmlns:a="http://schemas.openxmlformats.org/drawingml/2006/main" name="Office Theme">
   <a:themeElements>

</xml_diff>